<commit_message>
Update pitch deck with fresh app screenshots
Co-Authored-By: Claude Sonnet 4.6 <noreply@anthropic.com>
Claude-Session: https://claude.ai/code/session_0198rsFFZPR2bfJEenrNz6aM
</commit_message>
<xml_diff>
--- a/pitch/museo-pitch-v2.pptx
+++ b/pitch/museo-pitch-v2.pptx
@@ -3109,14 +3109,14 @@
         </p:nvSpPr>
         <p:spPr>
           <a:xfrm>
-            <a:off x="5903999" y="0"/>
-            <a:ext cx="3240000" cy="5148000"/>
+            <a:off x="5940000" y="0"/>
+            <a:ext cx="3204000" cy="5148000"/>
           </a:xfrm>
           <a:prstGeom prst="rect">
             <a:avLst/>
           </a:prstGeom>
           <a:solidFill>
-            <a:srgbClr val="F7F7F7"/>
+            <a:srgbClr val="F5F5F5"/>
           </a:solidFill>
           <a:ln>
             <a:noFill/>
@@ -3160,8 +3160,8 @@
         </p:blipFill>
         <p:spPr>
           <a:xfrm>
-            <a:off x="720000" y="648000"/>
-            <a:ext cx="648000" cy="353455"/>
+            <a:off x="720000" y="576000"/>
+            <a:ext cx="936000" cy="510545"/>
           </a:xfrm>
           <a:prstGeom prst="rect">
             <a:avLst/>
@@ -3176,8 +3176,8 @@
         </p:nvSpPr>
         <p:spPr>
           <a:xfrm>
-            <a:off x="720000" y="1512000"/>
-            <a:ext cx="4860000" cy="1260000"/>
+            <a:off x="720000" y="1800000"/>
+            <a:ext cx="4860000" cy="1152000"/>
           </a:xfrm>
           <a:prstGeom prst="rect">
             <a:avLst/>
@@ -3192,7 +3192,7 @@
           <a:p>
             <a:pPr algn="l"/>
             <a:r>
-              <a:rPr sz="3600" b="1" i="0">
+              <a:rPr sz="3400" b="1" i="0">
                 <a:solidFill>
                   <a:srgbClr val="111111"/>
                 </a:solidFill>
@@ -3210,8 +3210,8 @@
         </p:nvSpPr>
         <p:spPr>
           <a:xfrm>
-            <a:off x="720000" y="2844000"/>
-            <a:ext cx="648000" cy="54000"/>
+            <a:off x="720000" y="3060000"/>
+            <a:ext cx="720000" cy="54000"/>
           </a:xfrm>
           <a:prstGeom prst="rect">
             <a:avLst/>
@@ -3253,8 +3253,8 @@
         </p:nvSpPr>
         <p:spPr>
           <a:xfrm>
-            <a:off x="720000" y="2988000"/>
-            <a:ext cx="4680000" cy="720000"/>
+            <a:off x="720000" y="3240000"/>
+            <a:ext cx="4680000" cy="648000"/>
           </a:xfrm>
           <a:prstGeom prst="rect">
             <a:avLst/>
@@ -3269,13 +3269,13 @@
           <a:p>
             <a:pPr algn="l"/>
             <a:r>
-              <a:rPr sz="1200" b="0" i="0">
+              <a:rPr sz="1100" b="0" i="0">
                 <a:solidFill>
                   <a:srgbClr val="444444"/>
                 </a:solidFill>
               </a:rPr>
-              <a:t>La guía de arte con IA que tus visitantes
-llevan en el bolsillo.</a:t>
+              <a:t>La guía de arte con IA
+que tus visitantes llevan en el bolsillo.</a:t>
             </a:r>
           </a:p>
         </p:txBody>
@@ -3288,7 +3288,7 @@
         </p:nvSpPr>
         <p:spPr>
           <a:xfrm>
-            <a:off x="720000" y="4392000"/>
+            <a:off x="720000" y="4500000"/>
             <a:ext cx="3600000" cy="288000"/>
           </a:xfrm>
           <a:prstGeom prst="rect">
@@ -3322,8 +3322,8 @@
         </p:nvSpPr>
         <p:spPr>
           <a:xfrm>
-            <a:off x="6408000" y="324000"/>
-            <a:ext cx="2088000" cy="4500000"/>
+            <a:off x="6408000" y="288000"/>
+            <a:ext cx="2015999" cy="4572000"/>
           </a:xfrm>
           <a:prstGeom prst="rect">
             <a:avLst/>
@@ -3375,8 +3375,8 @@
         </p:blipFill>
         <p:spPr>
           <a:xfrm>
-            <a:off x="6498000" y="413999"/>
-            <a:ext cx="1908000" cy="4129108"/>
+            <a:off x="6472800" y="360000"/>
+            <a:ext cx="1886399" cy="4082361"/>
           </a:xfrm>
           <a:prstGeom prst="rect">
             <a:avLst/>
@@ -3418,16 +3418,16 @@
         <p:spPr>
           <a:xfrm>
             <a:off x="4500000" y="540000"/>
-            <a:ext cx="0" cy="4068000"/>
-          </a:xfrm>
-          <a:prstGeom prst="rect">
-            <a:avLst/>
-          </a:prstGeom>
-          <a:noFill/>
-          <a:ln w="12700">
-            <a:solidFill>
-              <a:srgbClr val="EEEEEE"/>
-            </a:solidFill>
+            <a:ext cx="7200" cy="4068000"/>
+          </a:xfrm>
+          <a:prstGeom prst="rect">
+            <a:avLst/>
+          </a:prstGeom>
+          <a:solidFill>
+            <a:srgbClr val="EEEEEE"/>
+          </a:solidFill>
+          <a:ln>
+            <a:noFill/>
           </a:ln>
         </p:spPr>
         <p:style>
@@ -3494,8 +3494,8 @@
         </p:nvSpPr>
         <p:spPr>
           <a:xfrm>
-            <a:off x="720000" y="2340000"/>
-            <a:ext cx="3420000" cy="1080000"/>
+            <a:off x="720000" y="2304000"/>
+            <a:ext cx="3420000" cy="1152000"/>
           </a:xfrm>
           <a:prstGeom prst="rect">
             <a:avLst/>
@@ -3515,8 +3515,8 @@
                   <a:srgbClr val="111111"/>
                 </a:solidFill>
               </a:rPr>
-              <a:t>de los visitantes sale sin entender
-lo que ha visto.</a:t>
+              <a:t>de los visitantes sale sin
+entender lo que ha visto.</a:t>
             </a:r>
           </a:p>
         </p:txBody>
@@ -3530,7 +3530,7 @@
         <p:spPr>
           <a:xfrm>
             <a:off x="4752000" y="720000"/>
-            <a:ext cx="3600000" cy="720000"/>
+            <a:ext cx="3780000" cy="720000"/>
           </a:xfrm>
           <a:prstGeom prst="rect">
             <a:avLst/>
@@ -3550,7 +3550,7 @@
                   <a:srgbClr val="444444"/>
                 </a:solidFill>
               </a:rPr>
-              <a:t>Los carteles son breves. Las audioguías, caras y lentas. La mayoría mira las obras en silencio y sigue andando.</a:t>
+              <a:t>Los carteles son breves. Las audioguías, caras y lentas. La mayoría mira en silencio y sigue andando.</a:t>
             </a:r>
           </a:p>
         </p:txBody>
@@ -3563,7 +3563,7 @@
         </p:nvSpPr>
         <p:spPr>
           <a:xfrm>
-            <a:off x="4752000" y="1800000"/>
+            <a:off x="4752000" y="1728000"/>
             <a:ext cx="90000" cy="1152000"/>
           </a:xfrm>
           <a:prstGeom prst="rect">
@@ -3606,8 +3606,8 @@
         </p:nvSpPr>
         <p:spPr>
           <a:xfrm>
-            <a:off x="4932000" y="1800000"/>
-            <a:ext cx="3420000" cy="1007999"/>
+            <a:off x="4932000" y="1728000"/>
+            <a:ext cx="3528000" cy="936000"/>
           </a:xfrm>
           <a:prstGeom prst="rect">
             <a:avLst/>
@@ -3627,7 +3627,8 @@
                   <a:srgbClr val="444444"/>
                 </a:solidFill>
               </a:rPr>
-              <a:t>"Fui al Prado, era precioso, pero no entendí casi nada."</a:t>
+              <a:t>"Fui al Prado, era precioso,
+pero no entendí casi nada."</a:t>
             </a:r>
           </a:p>
         </p:txBody>
@@ -3640,8 +3641,8 @@
         </p:nvSpPr>
         <p:spPr>
           <a:xfrm>
-            <a:off x="4932000" y="2736000"/>
-            <a:ext cx="3420000" cy="288000"/>
+            <a:off x="4932000" y="2628000"/>
+            <a:ext cx="3528000" cy="288000"/>
           </a:xfrm>
           <a:prstGeom prst="rect">
             <a:avLst/>
@@ -3674,8 +3675,8 @@
         </p:nvSpPr>
         <p:spPr>
           <a:xfrm>
-            <a:off x="4752000" y="3311999"/>
-            <a:ext cx="3600000" cy="900000"/>
+            <a:off x="4752000" y="3240000"/>
+            <a:ext cx="3780000" cy="900000"/>
           </a:xfrm>
           <a:prstGeom prst="rect">
             <a:avLst/>
@@ -3734,8 +3735,8 @@
         </p:nvSpPr>
         <p:spPr>
           <a:xfrm>
-            <a:off x="720000" y="540000"/>
-            <a:ext cx="4320000" cy="1007999"/>
+            <a:off x="720000" y="503999"/>
+            <a:ext cx="4680000" cy="1007999"/>
           </a:xfrm>
           <a:prstGeom prst="rect">
             <a:avLst/>
@@ -3769,8 +3770,8 @@
         </p:nvSpPr>
         <p:spPr>
           <a:xfrm>
-            <a:off x="720000" y="1800000"/>
-            <a:ext cx="576000" cy="54000"/>
+            <a:off x="720000" y="1728000"/>
+            <a:ext cx="648000" cy="50400"/>
           </a:xfrm>
           <a:prstGeom prst="rect">
             <a:avLst/>
@@ -3812,8 +3813,8 @@
         </p:nvSpPr>
         <p:spPr>
           <a:xfrm>
-            <a:off x="720000" y="1944000"/>
-            <a:ext cx="4320000" cy="432000"/>
+            <a:off x="720000" y="1872000"/>
+            <a:ext cx="4680000" cy="360000"/>
           </a:xfrm>
           <a:prstGeom prst="rect">
             <a:avLst/>
@@ -3833,7 +3834,7 @@
                   <a:srgbClr val="444444"/>
                 </a:solidFill>
               </a:rPr>
-              <a:t>Sin app de pago. Sin audioguía. Solo el móvil que el visitante ya lleva.</a:t>
+              <a:t>Sin app de pago. Solo el móvil que el visitante ya lleva en la mano.</a:t>
             </a:r>
           </a:p>
         </p:txBody>
@@ -3846,8 +3847,8 @@
         </p:nvSpPr>
         <p:spPr>
           <a:xfrm>
-            <a:off x="720000" y="2520000"/>
-            <a:ext cx="234000" cy="234000"/>
+            <a:off x="720000" y="2448000"/>
+            <a:ext cx="259200" cy="259200"/>
           </a:xfrm>
           <a:prstGeom prst="rect">
             <a:avLst/>
@@ -3889,8 +3890,8 @@
         </p:nvSpPr>
         <p:spPr>
           <a:xfrm>
-            <a:off x="720000" y="2538000"/>
-            <a:ext cx="234000" cy="216000"/>
+            <a:off x="720000" y="2469600"/>
+            <a:ext cx="259200" cy="216000"/>
           </a:xfrm>
           <a:prstGeom prst="rect">
             <a:avLst/>
@@ -3923,8 +3924,8 @@
         </p:nvSpPr>
         <p:spPr>
           <a:xfrm>
-            <a:off x="1044000" y="2520000"/>
-            <a:ext cx="4140000" cy="198000"/>
+            <a:off x="1080000" y="2448000"/>
+            <a:ext cx="3960000" cy="234000"/>
           </a:xfrm>
           <a:prstGeom prst="rect">
             <a:avLst/>
@@ -3957,8 +3958,8 @@
         </p:nvSpPr>
         <p:spPr>
           <a:xfrm>
-            <a:off x="1044000" y="2754000"/>
-            <a:ext cx="4140000" cy="432000"/>
+            <a:off x="1080000" y="2700000"/>
+            <a:ext cx="3960000" cy="396000"/>
           </a:xfrm>
           <a:prstGeom prst="rect">
             <a:avLst/>
@@ -3978,7 +3979,7 @@
                   <a:srgbClr val="444444"/>
                 </a:solidFill>
               </a:rPr>
-              <a:t>Escribe el nombre de la obra o escanea el QR del cartel</a:t>
+              <a:t>Escribe el nombre o escanea el QR del cartel</a:t>
             </a:r>
           </a:p>
         </p:txBody>
@@ -3991,8 +3992,8 @@
         </p:nvSpPr>
         <p:spPr>
           <a:xfrm>
-            <a:off x="720000" y="3276000"/>
-            <a:ext cx="234000" cy="234000"/>
+            <a:off x="720000" y="3240000"/>
+            <a:ext cx="259200" cy="259200"/>
           </a:xfrm>
           <a:prstGeom prst="rect">
             <a:avLst/>
@@ -4034,8 +4035,8 @@
         </p:nvSpPr>
         <p:spPr>
           <a:xfrm>
-            <a:off x="720000" y="3294000"/>
-            <a:ext cx="234000" cy="216000"/>
+            <a:off x="720000" y="3261600"/>
+            <a:ext cx="259200" cy="216000"/>
           </a:xfrm>
           <a:prstGeom prst="rect">
             <a:avLst/>
@@ -4068,8 +4069,8 @@
         </p:nvSpPr>
         <p:spPr>
           <a:xfrm>
-            <a:off x="1044000" y="3276000"/>
-            <a:ext cx="4140000" cy="198000"/>
+            <a:off x="1080000" y="3240000"/>
+            <a:ext cx="3960000" cy="234000"/>
           </a:xfrm>
           <a:prstGeom prst="rect">
             <a:avLst/>
@@ -4102,8 +4103,8 @@
         </p:nvSpPr>
         <p:spPr>
           <a:xfrm>
-            <a:off x="1044000" y="3510000"/>
-            <a:ext cx="4140000" cy="432000"/>
+            <a:off x="1080000" y="3491999"/>
+            <a:ext cx="3960000" cy="396000"/>
           </a:xfrm>
           <a:prstGeom prst="rect">
             <a:avLst/>
@@ -4123,7 +4124,7 @@
                   <a:srgbClr val="444444"/>
                 </a:solidFill>
               </a:rPr>
-              <a:t>15 datos precisos adaptados al nivel elegido (niño, curioso, experto)</a:t>
+              <a:t>15 datos precisos, en el idioma y nivel elegido</a:t>
             </a:r>
           </a:p>
         </p:txBody>
@@ -4137,7 +4138,7 @@
         <p:spPr>
           <a:xfrm>
             <a:off x="720000" y="4031999"/>
-            <a:ext cx="234000" cy="234000"/>
+            <a:ext cx="259200" cy="259200"/>
           </a:xfrm>
           <a:prstGeom prst="rect">
             <a:avLst/>
@@ -4179,8 +4180,8 @@
         </p:nvSpPr>
         <p:spPr>
           <a:xfrm>
-            <a:off x="720000" y="4050000"/>
-            <a:ext cx="234000" cy="216000"/>
+            <a:off x="720000" y="4053600"/>
+            <a:ext cx="259200" cy="216000"/>
           </a:xfrm>
           <a:prstGeom prst="rect">
             <a:avLst/>
@@ -4213,8 +4214,8 @@
         </p:nvSpPr>
         <p:spPr>
           <a:xfrm>
-            <a:off x="1044000" y="4031999"/>
-            <a:ext cx="4140000" cy="198000"/>
+            <a:off x="1080000" y="4031999"/>
+            <a:ext cx="3960000" cy="234000"/>
           </a:xfrm>
           <a:prstGeom prst="rect">
             <a:avLst/>
@@ -4247,8 +4248,8 @@
         </p:nvSpPr>
         <p:spPr>
           <a:xfrm>
-            <a:off x="1044000" y="4266000"/>
-            <a:ext cx="4140000" cy="432000"/>
+            <a:off x="1080000" y="4283999"/>
+            <a:ext cx="3960000" cy="396000"/>
           </a:xfrm>
           <a:prstGeom prst="rect">
             <a:avLst/>
@@ -4281,8 +4282,8 @@
         </p:nvSpPr>
         <p:spPr>
           <a:xfrm>
-            <a:off x="5760000" y="288000"/>
-            <a:ext cx="1512000" cy="3240000"/>
+            <a:off x="5688000" y="288000"/>
+            <a:ext cx="1440000" cy="3131999"/>
           </a:xfrm>
           <a:prstGeom prst="rect">
             <a:avLst/>
@@ -4334,8 +4335,8 @@
         </p:blipFill>
         <p:spPr>
           <a:xfrm>
-            <a:off x="5832000" y="360000"/>
-            <a:ext cx="1368000" cy="2960492"/>
+            <a:off x="5752800" y="360000"/>
+            <a:ext cx="1310400" cy="2835840"/>
           </a:xfrm>
           <a:prstGeom prst="rect">
             <a:avLst/>
@@ -4350,8 +4351,8 @@
         </p:nvSpPr>
         <p:spPr>
           <a:xfrm>
-            <a:off x="7452000" y="648000"/>
-            <a:ext cx="1512000" cy="3240000"/>
+            <a:off x="7343999" y="648000"/>
+            <a:ext cx="1440000" cy="3131999"/>
           </a:xfrm>
           <a:prstGeom prst="rect">
             <a:avLst/>
@@ -4403,8 +4404,8 @@
         </p:blipFill>
         <p:spPr>
           <a:xfrm>
-            <a:off x="7523999" y="720000"/>
-            <a:ext cx="1368000" cy="2960492"/>
+            <a:off x="7408799" y="720000"/>
+            <a:ext cx="1310400" cy="2835840"/>
           </a:xfrm>
           <a:prstGeom prst="rect">
             <a:avLst/>
@@ -4445,8 +4446,8 @@
         </p:nvSpPr>
         <p:spPr>
           <a:xfrm>
-            <a:off x="720000" y="288000"/>
-            <a:ext cx="1872000" cy="4068000"/>
+            <a:off x="720000" y="251999"/>
+            <a:ext cx="1944000" cy="4212000"/>
           </a:xfrm>
           <a:prstGeom prst="rect">
             <a:avLst/>
@@ -4498,8 +4499,8 @@
         </p:blipFill>
         <p:spPr>
           <a:xfrm>
-            <a:off x="792000" y="360000"/>
-            <a:ext cx="1728000" cy="3739569"/>
+            <a:off x="784800" y="323999"/>
+            <a:ext cx="1814400" cy="3926548"/>
           </a:xfrm>
           <a:prstGeom prst="rect">
             <a:avLst/>
@@ -4514,8 +4515,8 @@
         </p:nvSpPr>
         <p:spPr>
           <a:xfrm>
-            <a:off x="3060000" y="540000"/>
-            <a:ext cx="5220000" cy="864000"/>
+            <a:off x="3168000" y="503999"/>
+            <a:ext cx="5400000" cy="864000"/>
           </a:xfrm>
           <a:prstGeom prst="rect">
             <a:avLst/>
@@ -4549,8 +4550,8 @@
         </p:nvSpPr>
         <p:spPr>
           <a:xfrm>
-            <a:off x="3060000" y="1620000"/>
-            <a:ext cx="576000" cy="54000"/>
+            <a:off x="3168000" y="1584000"/>
+            <a:ext cx="648000" cy="50400"/>
           </a:xfrm>
           <a:prstGeom prst="rect">
             <a:avLst/>
@@ -4592,8 +4593,8 @@
         </p:nvSpPr>
         <p:spPr>
           <a:xfrm>
-            <a:off x="3060000" y="1764000"/>
-            <a:ext cx="5220000" cy="540000"/>
+            <a:off x="3168000" y="1728000"/>
+            <a:ext cx="5400000" cy="432000"/>
           </a:xfrm>
           <a:prstGeom prst="rect">
             <a:avLst/>
@@ -4626,14 +4627,14 @@
         </p:nvSpPr>
         <p:spPr>
           <a:xfrm>
-            <a:off x="3060000" y="2520000"/>
-            <a:ext cx="1728000" cy="1728000"/>
+            <a:off x="3168000" y="2448000"/>
+            <a:ext cx="1764000" cy="1800000"/>
           </a:xfrm>
           <a:prstGeom prst="rect">
             <a:avLst/>
           </a:prstGeom>
           <a:solidFill>
-            <a:srgbClr val="F7F7F7"/>
+            <a:srgbClr val="F5F5F5"/>
           </a:solidFill>
           <a:ln w="12700">
             <a:solidFill>
@@ -4671,8 +4672,8 @@
         </p:nvSpPr>
         <p:spPr>
           <a:xfrm>
-            <a:off x="3204000" y="2628000"/>
-            <a:ext cx="1440000" cy="324000"/>
+            <a:off x="3312000" y="2556000"/>
+            <a:ext cx="1476000" cy="324000"/>
           </a:xfrm>
           <a:prstGeom prst="rect">
             <a:avLst/>
@@ -4705,8 +4706,8 @@
         </p:nvSpPr>
         <p:spPr>
           <a:xfrm>
-            <a:off x="3204000" y="2988000"/>
-            <a:ext cx="1440000" cy="251999"/>
+            <a:off x="3312000" y="2916000"/>
+            <a:ext cx="1476000" cy="251999"/>
           </a:xfrm>
           <a:prstGeom prst="rect">
             <a:avLst/>
@@ -4739,8 +4740,8 @@
         </p:nvSpPr>
         <p:spPr>
           <a:xfrm>
-            <a:off x="3204000" y="3276000"/>
-            <a:ext cx="1440000" cy="720000"/>
+            <a:off x="3312000" y="3204000"/>
+            <a:ext cx="1476000" cy="900000"/>
           </a:xfrm>
           <a:prstGeom prst="rect">
             <a:avLst/>
@@ -4774,8 +4775,8 @@
         </p:nvSpPr>
         <p:spPr>
           <a:xfrm>
-            <a:off x="4932000" y="2520000"/>
-            <a:ext cx="1728000" cy="1728000"/>
+            <a:off x="5076000" y="2448000"/>
+            <a:ext cx="1764000" cy="1800000"/>
           </a:xfrm>
           <a:prstGeom prst="rect">
             <a:avLst/>
@@ -4817,8 +4818,8 @@
         </p:nvSpPr>
         <p:spPr>
           <a:xfrm>
-            <a:off x="5076000" y="2628000"/>
-            <a:ext cx="1440000" cy="324000"/>
+            <a:off x="5220000" y="2556000"/>
+            <a:ext cx="1476000" cy="324000"/>
           </a:xfrm>
           <a:prstGeom prst="rect">
             <a:avLst/>
@@ -4851,8 +4852,8 @@
         </p:nvSpPr>
         <p:spPr>
           <a:xfrm>
-            <a:off x="5076000" y="2988000"/>
-            <a:ext cx="1440000" cy="251999"/>
+            <a:off x="5220000" y="2916000"/>
+            <a:ext cx="1476000" cy="251999"/>
           </a:xfrm>
           <a:prstGeom prst="rect">
             <a:avLst/>
@@ -4885,8 +4886,8 @@
         </p:nvSpPr>
         <p:spPr>
           <a:xfrm>
-            <a:off x="5076000" y="3276000"/>
-            <a:ext cx="1440000" cy="720000"/>
+            <a:off x="5220000" y="3204000"/>
+            <a:ext cx="1476000" cy="900000"/>
           </a:xfrm>
           <a:prstGeom prst="rect">
             <a:avLst/>
@@ -4906,8 +4907,8 @@
                   <a:srgbClr val="444444"/>
                 </a:solidFill>
               </a:rPr>
-              <a:t>Contexto histórico y
-movimientos artísticos.</a:t>
+              <a:t>Contexto histórico
+y movimientos artísticos.</a:t>
             </a:r>
           </a:p>
         </p:txBody>
@@ -4920,14 +4921,14 @@
         </p:nvSpPr>
         <p:spPr>
           <a:xfrm>
-            <a:off x="6803999" y="2520000"/>
-            <a:ext cx="1728000" cy="1728000"/>
+            <a:off x="6984000" y="2448000"/>
+            <a:ext cx="1764000" cy="1800000"/>
           </a:xfrm>
           <a:prstGeom prst="rect">
             <a:avLst/>
           </a:prstGeom>
           <a:solidFill>
-            <a:srgbClr val="F7F7F7"/>
+            <a:srgbClr val="F5F5F5"/>
           </a:solidFill>
           <a:ln w="12700">
             <a:solidFill>
@@ -4965,8 +4966,8 @@
         </p:nvSpPr>
         <p:spPr>
           <a:xfrm>
-            <a:off x="6947999" y="2628000"/>
-            <a:ext cx="1440000" cy="324000"/>
+            <a:off x="7128000" y="2556000"/>
+            <a:ext cx="1476000" cy="324000"/>
           </a:xfrm>
           <a:prstGeom prst="rect">
             <a:avLst/>
@@ -4999,8 +5000,8 @@
         </p:nvSpPr>
         <p:spPr>
           <a:xfrm>
-            <a:off x="6947999" y="2988000"/>
-            <a:ext cx="1440000" cy="251999"/>
+            <a:off x="7128000" y="2916000"/>
+            <a:ext cx="1476000" cy="251999"/>
           </a:xfrm>
           <a:prstGeom prst="rect">
             <a:avLst/>
@@ -5033,8 +5034,8 @@
         </p:nvSpPr>
         <p:spPr>
           <a:xfrm>
-            <a:off x="6947999" y="3276000"/>
-            <a:ext cx="1440000" cy="720000"/>
+            <a:off x="7128000" y="3204000"/>
+            <a:ext cx="1476000" cy="900000"/>
           </a:xfrm>
           <a:prstGeom prst="rect">
             <a:avLst/>
@@ -5068,8 +5069,8 @@
         </p:nvSpPr>
         <p:spPr>
           <a:xfrm>
-            <a:off x="3060000" y="4428000"/>
-            <a:ext cx="5220000" cy="288000"/>
+            <a:off x="3168000" y="4428000"/>
+            <a:ext cx="5400000" cy="288000"/>
           </a:xfrm>
           <a:prstGeom prst="rect">
             <a:avLst/>
@@ -5122,14 +5123,57 @@
       <p:grpSpPr/>
       <p:sp>
         <p:nvSpPr>
-          <p:cNvPr id="2" name="TextBox 1"/>
+          <p:cNvPr id="2" name="Rectangle 1"/>
+          <p:cNvSpPr/>
+          <p:nvPr/>
+        </p:nvSpPr>
+        <p:spPr>
+          <a:xfrm>
+            <a:off x="5472000" y="540000"/>
+            <a:ext cx="7200" cy="4140000"/>
+          </a:xfrm>
+          <a:prstGeom prst="rect">
+            <a:avLst/>
+          </a:prstGeom>
+          <a:solidFill>
+            <a:srgbClr val="EEEEEE"/>
+          </a:solidFill>
+          <a:ln>
+            <a:noFill/>
+          </a:ln>
+        </p:spPr>
+        <p:style>
+          <a:lnRef idx="1">
+            <a:schemeClr val="accent1"/>
+          </a:lnRef>
+          <a:fillRef idx="3">
+            <a:schemeClr val="accent1"/>
+          </a:fillRef>
+          <a:effectRef idx="2">
+            <a:schemeClr val="accent1"/>
+          </a:effectRef>
+          <a:fontRef idx="minor">
+            <a:schemeClr val="lt1"/>
+          </a:fontRef>
+        </p:style>
+        <p:txBody>
+          <a:bodyPr rtlCol="0" anchor="ctr"/>
+          <a:lstStyle/>
+          <a:p>
+            <a:pPr algn="ctr"/>
+          </a:p>
+        </p:txBody>
+      </p:sp>
+      <p:sp>
+        <p:nvSpPr>
+          <p:cNvPr id="3" name="TextBox 2"/>
           <p:cNvSpPr txBox="1"/>
           <p:nvPr/>
         </p:nvSpPr>
         <p:spPr>
           <a:xfrm>
-            <a:off x="720000" y="540000"/>
-            <a:ext cx="4680000" cy="936000"/>
+            <a:off x="720000" y="503999"/>
+            <a:ext cx="4500000" cy="936000"/>
           </a:xfrm>
           <a:prstGeom prst="rect">
             <a:avLst/>
@@ -5157,14 +5201,14 @@
       </p:sp>
       <p:sp>
         <p:nvSpPr>
-          <p:cNvPr id="3" name="Rectangle 2"/>
+          <p:cNvPr id="4" name="Rectangle 3"/>
           <p:cNvSpPr/>
           <p:nvPr/>
         </p:nvSpPr>
         <p:spPr>
           <a:xfrm>
-            <a:off x="720000" y="1692000"/>
-            <a:ext cx="576000" cy="54000"/>
+            <a:off x="720000" y="1655999"/>
+            <a:ext cx="648000" cy="50400"/>
           </a:xfrm>
           <a:prstGeom prst="rect">
             <a:avLst/>
@@ -5200,7 +5244,7 @@
       </p:sp>
       <p:sp>
         <p:nvSpPr>
-          <p:cNvPr id="4" name="TextBox 3"/>
+          <p:cNvPr id="5" name="TextBox 4"/>
           <p:cNvSpPr txBox="1"/>
           <p:nvPr/>
         </p:nvSpPr>
@@ -5234,13 +5278,13 @@
       </p:sp>
       <p:sp>
         <p:nvSpPr>
-          <p:cNvPr id="5" name="TextBox 4"/>
+          <p:cNvPr id="6" name="TextBox 5"/>
           <p:cNvSpPr txBox="1"/>
           <p:nvPr/>
         </p:nvSpPr>
         <p:spPr>
           <a:xfrm>
-            <a:off x="1007999" y="1872000"/>
+            <a:off x="1044000" y="1872000"/>
             <a:ext cx="4140000" cy="468000"/>
           </a:xfrm>
           <a:prstGeom prst="rect">
@@ -5268,23 +5312,23 @@
       </p:sp>
       <p:sp>
         <p:nvSpPr>
-          <p:cNvPr id="6" name="Rectangle 5"/>
+          <p:cNvPr id="7" name="Rectangle 6"/>
           <p:cNvSpPr/>
           <p:nvPr/>
         </p:nvSpPr>
         <p:spPr>
           <a:xfrm>
-            <a:off x="720000" y="2340000"/>
-            <a:ext cx="4500000" cy="0"/>
-          </a:xfrm>
-          <a:prstGeom prst="rect">
-            <a:avLst/>
-          </a:prstGeom>
-          <a:noFill/>
-          <a:ln w="12700">
-            <a:solidFill>
-              <a:srgbClr val="EEEEEE"/>
-            </a:solidFill>
+            <a:off x="720000" y="2376000"/>
+            <a:ext cx="4500000" cy="7200"/>
+          </a:xfrm>
+          <a:prstGeom prst="rect">
+            <a:avLst/>
+          </a:prstGeom>
+          <a:solidFill>
+            <a:srgbClr val="EEEEEE"/>
+          </a:solidFill>
+          <a:ln>
+            <a:noFill/>
           </a:ln>
         </p:spPr>
         <p:style>
@@ -5311,13 +5355,13 @@
       </p:sp>
       <p:sp>
         <p:nvSpPr>
-          <p:cNvPr id="7" name="TextBox 6"/>
+          <p:cNvPr id="8" name="TextBox 7"/>
           <p:cNvSpPr txBox="1"/>
           <p:nvPr/>
         </p:nvSpPr>
         <p:spPr>
           <a:xfrm>
-            <a:off x="720000" y="2430000"/>
+            <a:off x="720000" y="2448000"/>
             <a:ext cx="288000" cy="324000"/>
           </a:xfrm>
           <a:prstGeom prst="rect">
@@ -5345,13 +5389,13 @@
       </p:sp>
       <p:sp>
         <p:nvSpPr>
-          <p:cNvPr id="8" name="TextBox 7"/>
+          <p:cNvPr id="9" name="TextBox 8"/>
           <p:cNvSpPr txBox="1"/>
           <p:nvPr/>
         </p:nvSpPr>
         <p:spPr>
           <a:xfrm>
-            <a:off x="1007999" y="2430000"/>
+            <a:off x="1044000" y="2448000"/>
             <a:ext cx="4140000" cy="468000"/>
           </a:xfrm>
           <a:prstGeom prst="rect">
@@ -5372,30 +5416,30 @@
                   <a:srgbClr val="444444"/>
                 </a:solidFill>
               </a:rPr>
-              <a:t>Tu colección curada — cada obra es tappable y genera contenido</a:t>
-            </a:r>
-          </a:p>
-        </p:txBody>
-      </p:sp>
-      <p:sp>
-        <p:nvSpPr>
-          <p:cNvPr id="9" name="Rectangle 8"/>
+              <a:t>Tu colección curada — cada obra tappable y genera contenido</a:t>
+            </a:r>
+          </a:p>
+        </p:txBody>
+      </p:sp>
+      <p:sp>
+        <p:nvSpPr>
+          <p:cNvPr id="10" name="Rectangle 9"/>
           <p:cNvSpPr/>
           <p:nvPr/>
         </p:nvSpPr>
         <p:spPr>
           <a:xfrm>
-            <a:off x="720000" y="2898000"/>
-            <a:ext cx="4500000" cy="0"/>
-          </a:xfrm>
-          <a:prstGeom prst="rect">
-            <a:avLst/>
-          </a:prstGeom>
-          <a:noFill/>
-          <a:ln w="12700">
-            <a:solidFill>
-              <a:srgbClr val="EEEEEE"/>
-            </a:solidFill>
+            <a:off x="720000" y="2952000"/>
+            <a:ext cx="4500000" cy="7200"/>
+          </a:xfrm>
+          <a:prstGeom prst="rect">
+            <a:avLst/>
+          </a:prstGeom>
+          <a:solidFill>
+            <a:srgbClr val="EEEEEE"/>
+          </a:solidFill>
+          <a:ln>
+            <a:noFill/>
           </a:ln>
         </p:spPr>
         <p:style>
@@ -5422,13 +5466,13 @@
       </p:sp>
       <p:sp>
         <p:nvSpPr>
-          <p:cNvPr id="10" name="TextBox 9"/>
+          <p:cNvPr id="11" name="TextBox 10"/>
           <p:cNvSpPr txBox="1"/>
           <p:nvPr/>
         </p:nvSpPr>
         <p:spPr>
           <a:xfrm>
-            <a:off x="720000" y="2988000"/>
+            <a:off x="720000" y="3024000"/>
             <a:ext cx="288000" cy="324000"/>
           </a:xfrm>
           <a:prstGeom prst="rect">
@@ -5456,13 +5500,13 @@
       </p:sp>
       <p:sp>
         <p:nvSpPr>
-          <p:cNvPr id="11" name="TextBox 10"/>
+          <p:cNvPr id="12" name="TextBox 11"/>
           <p:cNvSpPr txBox="1"/>
           <p:nvPr/>
         </p:nvSpPr>
         <p:spPr>
           <a:xfrm>
-            <a:off x="1007999" y="2988000"/>
+            <a:off x="1044000" y="3024000"/>
             <a:ext cx="4140000" cy="468000"/>
           </a:xfrm>
           <a:prstGeom prst="rect">
@@ -5483,30 +5527,30 @@
                   <a:srgbClr val="444444"/>
                 </a:solidFill>
               </a:rPr>
-              <a:t>Aparece automáticamente cuando alguien busca una obra tuya</a:t>
-            </a:r>
-          </a:p>
-        </p:txBody>
-      </p:sp>
-      <p:sp>
-        <p:nvSpPr>
-          <p:cNvPr id="12" name="Rectangle 11"/>
+              <a:t>Aparece automáticamente en búsquedas de tus obras</a:t>
+            </a:r>
+          </a:p>
+        </p:txBody>
+      </p:sp>
+      <p:sp>
+        <p:nvSpPr>
+          <p:cNvPr id="13" name="Rectangle 12"/>
           <p:cNvSpPr/>
           <p:nvPr/>
         </p:nvSpPr>
         <p:spPr>
           <a:xfrm>
-            <a:off x="720000" y="3456000"/>
-            <a:ext cx="4500000" cy="0"/>
-          </a:xfrm>
-          <a:prstGeom prst="rect">
-            <a:avLst/>
-          </a:prstGeom>
-          <a:noFill/>
-          <a:ln w="12700">
-            <a:solidFill>
-              <a:srgbClr val="EEEEEE"/>
-            </a:solidFill>
+            <a:off x="720000" y="3528000"/>
+            <a:ext cx="4500000" cy="7200"/>
+          </a:xfrm>
+          <a:prstGeom prst="rect">
+            <a:avLst/>
+          </a:prstGeom>
+          <a:solidFill>
+            <a:srgbClr val="EEEEEE"/>
+          </a:solidFill>
+          <a:ln>
+            <a:noFill/>
           </a:ln>
         </p:spPr>
         <p:style>
@@ -5533,13 +5577,13 @@
       </p:sp>
       <p:sp>
         <p:nvSpPr>
-          <p:cNvPr id="13" name="TextBox 12"/>
+          <p:cNvPr id="14" name="TextBox 13"/>
           <p:cNvSpPr txBox="1"/>
           <p:nvPr/>
         </p:nvSpPr>
         <p:spPr>
           <a:xfrm>
-            <a:off x="720000" y="3546000"/>
+            <a:off x="720000" y="3600000"/>
             <a:ext cx="288000" cy="324000"/>
           </a:xfrm>
           <a:prstGeom prst="rect">
@@ -5567,13 +5611,13 @@
       </p:sp>
       <p:sp>
         <p:nvSpPr>
-          <p:cNvPr id="14" name="TextBox 13"/>
+          <p:cNvPr id="15" name="TextBox 14"/>
           <p:cNvSpPr txBox="1"/>
           <p:nvPr/>
         </p:nvSpPr>
         <p:spPr>
           <a:xfrm>
-            <a:off x="1007999" y="3546000"/>
+            <a:off x="1044000" y="3600000"/>
             <a:ext cx="4140000" cy="468000"/>
           </a:xfrm>
           <a:prstGeom prst="rect">
@@ -5594,30 +5638,30 @@
                   <a:srgbClr val="444444"/>
                 </a:solidFill>
               </a:rPr>
-              <a:t>Datos reales: top obras buscadas, idiomas y tipo de audiencia</a:t>
-            </a:r>
-          </a:p>
-        </p:txBody>
-      </p:sp>
-      <p:sp>
-        <p:nvSpPr>
-          <p:cNvPr id="15" name="Rectangle 14"/>
+              <a:t>Datos reales: top obras, idiomas y perfil de audiencia</a:t>
+            </a:r>
+          </a:p>
+        </p:txBody>
+      </p:sp>
+      <p:sp>
+        <p:nvSpPr>
+          <p:cNvPr id="16" name="Rectangle 15"/>
           <p:cNvSpPr/>
           <p:nvPr/>
         </p:nvSpPr>
         <p:spPr>
           <a:xfrm>
-            <a:off x="720000" y="4014000"/>
-            <a:ext cx="4500000" cy="0"/>
-          </a:xfrm>
-          <a:prstGeom prst="rect">
-            <a:avLst/>
-          </a:prstGeom>
-          <a:noFill/>
-          <a:ln w="12700">
-            <a:solidFill>
-              <a:srgbClr val="EEEEEE"/>
-            </a:solidFill>
+            <a:off x="720000" y="4104000"/>
+            <a:ext cx="4500000" cy="7200"/>
+          </a:xfrm>
+          <a:prstGeom prst="rect">
+            <a:avLst/>
+          </a:prstGeom>
+          <a:solidFill>
+            <a:srgbClr val="EEEEEE"/>
+          </a:solidFill>
+          <a:ln>
+            <a:noFill/>
           </a:ln>
         </p:spPr>
         <p:style>
@@ -5644,13 +5688,13 @@
       </p:sp>
       <p:sp>
         <p:nvSpPr>
-          <p:cNvPr id="16" name="TextBox 15"/>
+          <p:cNvPr id="17" name="TextBox 16"/>
           <p:cNvSpPr txBox="1"/>
           <p:nvPr/>
         </p:nvSpPr>
         <p:spPr>
           <a:xfrm>
-            <a:off x="720000" y="4104000"/>
+            <a:off x="720000" y="4176000"/>
             <a:ext cx="288000" cy="324000"/>
           </a:xfrm>
           <a:prstGeom prst="rect">
@@ -5678,13 +5722,13 @@
       </p:sp>
       <p:sp>
         <p:nvSpPr>
-          <p:cNvPr id="17" name="TextBox 16"/>
+          <p:cNvPr id="18" name="TextBox 17"/>
           <p:cNvSpPr txBox="1"/>
           <p:nvPr/>
         </p:nvSpPr>
         <p:spPr>
           <a:xfrm>
-            <a:off x="1007999" y="4104000"/>
+            <a:off x="1044000" y="4176000"/>
             <a:ext cx="4140000" cy="468000"/>
           </a:xfrm>
           <a:prstGeom prst="rect">
@@ -5712,23 +5756,57 @@
       </p:sp>
       <p:sp>
         <p:nvSpPr>
-          <p:cNvPr id="18" name="Rectangle 17"/>
+          <p:cNvPr id="19" name="TextBox 18"/>
+          <p:cNvSpPr txBox="1"/>
+          <p:nvPr/>
+        </p:nvSpPr>
+        <p:spPr>
+          <a:xfrm>
+            <a:off x="5688000" y="540000"/>
+            <a:ext cx="3240000" cy="288000"/>
+          </a:xfrm>
+          <a:prstGeom prst="rect">
+            <a:avLst/>
+          </a:prstGeom>
+          <a:noFill/>
+        </p:spPr>
+        <p:txBody>
+          <a:bodyPr wrap="square">
+            <a:spAutoFit/>
+          </a:bodyPr>
+          <a:lstStyle/>
+          <a:p>
+            <a:pPr algn="l"/>
+            <a:r>
+              <a:rPr sz="900" b="0" i="0">
+                <a:solidFill>
+                  <a:srgbClr val="888888"/>
+                </a:solidFill>
+              </a:rPr>
+              <a:t>Inteligencia que no tenías antes</a:t>
+            </a:r>
+          </a:p>
+        </p:txBody>
+      </p:sp>
+      <p:sp>
+        <p:nvSpPr>
+          <p:cNvPr id="20" name="Rectangle 19"/>
           <p:cNvSpPr/>
           <p:nvPr/>
         </p:nvSpPr>
         <p:spPr>
           <a:xfrm>
-            <a:off x="5400000" y="540000"/>
-            <a:ext cx="0" cy="4140000"/>
-          </a:xfrm>
-          <a:prstGeom prst="rect">
-            <a:avLst/>
-          </a:prstGeom>
-          <a:noFill/>
-          <a:ln w="12700">
-            <a:solidFill>
-              <a:srgbClr val="EEEEEE"/>
-            </a:solidFill>
+            <a:off x="5688000" y="1080000"/>
+            <a:ext cx="3024000" cy="1044000"/>
+          </a:xfrm>
+          <a:prstGeom prst="rect">
+            <a:avLst/>
+          </a:prstGeom>
+          <a:solidFill>
+            <a:srgbClr val="F5F5F5"/>
+          </a:solidFill>
+          <a:ln>
+            <a:noFill/>
           </a:ln>
         </p:spPr>
         <p:style>
@@ -5755,14 +5833,14 @@
       </p:sp>
       <p:sp>
         <p:nvSpPr>
-          <p:cNvPr id="19" name="TextBox 18"/>
+          <p:cNvPr id="21" name="TextBox 20"/>
           <p:cNvSpPr txBox="1"/>
           <p:nvPr/>
         </p:nvSpPr>
         <p:spPr>
           <a:xfrm>
-            <a:off x="5616000" y="540000"/>
-            <a:ext cx="3240000" cy="324000"/>
+            <a:off x="5868000" y="1224000"/>
+            <a:ext cx="2700000" cy="468000"/>
           </a:xfrm>
           <a:prstGeom prst="rect">
             <a:avLst/>
@@ -5777,32 +5855,66 @@
           <a:p>
             <a:pPr algn="l"/>
             <a:r>
-              <a:rPr sz="950" b="0" i="0">
+              <a:rPr sz="1800" b="1" i="0">
+                <a:solidFill>
+                  <a:srgbClr val="111111"/>
+                </a:solidFill>
+              </a:rPr>
+              <a:t>Top 10</a:t>
+            </a:r>
+          </a:p>
+        </p:txBody>
+      </p:sp>
+      <p:sp>
+        <p:nvSpPr>
+          <p:cNvPr id="22" name="TextBox 21"/>
+          <p:cNvSpPr txBox="1"/>
+          <p:nvPr/>
+        </p:nvSpPr>
+        <p:spPr>
+          <a:xfrm>
+            <a:off x="5868000" y="1728000"/>
+            <a:ext cx="2700000" cy="288000"/>
+          </a:xfrm>
+          <a:prstGeom prst="rect">
+            <a:avLst/>
+          </a:prstGeom>
+          <a:noFill/>
+        </p:spPr>
+        <p:txBody>
+          <a:bodyPr wrap="square">
+            <a:spAutoFit/>
+          </a:bodyPr>
+          <a:lstStyle/>
+          <a:p>
+            <a:pPr algn="l"/>
+            <a:r>
+              <a:rPr sz="750" b="0" i="0">
                 <a:solidFill>
                   <a:srgbClr val="888888"/>
                 </a:solidFill>
               </a:rPr>
-              <a:t>Inteligencia que no tenías antes</a:t>
-            </a:r>
-          </a:p>
-        </p:txBody>
-      </p:sp>
-      <p:sp>
-        <p:nvSpPr>
-          <p:cNvPr id="20" name="Rectangle 19"/>
+              <a:t>Obras más buscadas este mes</a:t>
+            </a:r>
+          </a:p>
+        </p:txBody>
+      </p:sp>
+      <p:sp>
+        <p:nvSpPr>
+          <p:cNvPr id="23" name="Rectangle 22"/>
           <p:cNvSpPr/>
           <p:nvPr/>
         </p:nvSpPr>
         <p:spPr>
           <a:xfrm>
-            <a:off x="5616000" y="1007999"/>
-            <a:ext cx="3060000" cy="1007999"/>
+            <a:off x="5688000" y="2304000"/>
+            <a:ext cx="3024000" cy="1044000"/>
           </a:xfrm>
           <a:prstGeom prst="rect">
             <a:avLst/>
           </a:prstGeom>
           <a:solidFill>
-            <a:srgbClr val="F7F7F7"/>
+            <a:srgbClr val="F5F5F5"/>
           </a:solidFill>
           <a:ln>
             <a:noFill/>
@@ -5832,13 +5944,13 @@
       </p:sp>
       <p:sp>
         <p:nvSpPr>
-          <p:cNvPr id="21" name="TextBox 20"/>
+          <p:cNvPr id="24" name="TextBox 23"/>
           <p:cNvSpPr txBox="1"/>
           <p:nvPr/>
         </p:nvSpPr>
         <p:spPr>
           <a:xfrm>
-            <a:off x="5796000" y="1152000"/>
+            <a:off x="5868000" y="2448000"/>
             <a:ext cx="2700000" cy="468000"/>
           </a:xfrm>
           <a:prstGeom prst="rect">
@@ -5859,20 +5971,20 @@
                   <a:srgbClr val="111111"/>
                 </a:solidFill>
               </a:rPr>
-              <a:t>Top 10</a:t>
-            </a:r>
-          </a:p>
-        </p:txBody>
-      </p:sp>
-      <p:sp>
-        <p:nvSpPr>
-          <p:cNvPr id="22" name="TextBox 21"/>
+              <a:t>ES / EN</a:t>
+            </a:r>
+          </a:p>
+        </p:txBody>
+      </p:sp>
+      <p:sp>
+        <p:nvSpPr>
+          <p:cNvPr id="25" name="TextBox 24"/>
           <p:cNvSpPr txBox="1"/>
           <p:nvPr/>
         </p:nvSpPr>
         <p:spPr>
           <a:xfrm>
-            <a:off x="5796000" y="1655999"/>
+            <a:off x="5868000" y="2952000"/>
             <a:ext cx="2700000" cy="288000"/>
           </a:xfrm>
           <a:prstGeom prst="rect">
@@ -5893,27 +6005,27 @@
                   <a:srgbClr val="888888"/>
                 </a:solidFill>
               </a:rPr>
-              <a:t>Obras más buscadas este mes</a:t>
-            </a:r>
-          </a:p>
-        </p:txBody>
-      </p:sp>
-      <p:sp>
-        <p:nvSpPr>
-          <p:cNvPr id="23" name="Rectangle 22"/>
+              <a:t>Distribución por idioma</a:t>
+            </a:r>
+          </a:p>
+        </p:txBody>
+      </p:sp>
+      <p:sp>
+        <p:nvSpPr>
+          <p:cNvPr id="26" name="Rectangle 25"/>
           <p:cNvSpPr/>
           <p:nvPr/>
         </p:nvSpPr>
         <p:spPr>
           <a:xfrm>
-            <a:off x="5616000" y="2196000"/>
-            <a:ext cx="3060000" cy="1007999"/>
+            <a:off x="5688000" y="3528000"/>
+            <a:ext cx="3024000" cy="1044000"/>
           </a:xfrm>
           <a:prstGeom prst="rect">
             <a:avLst/>
           </a:prstGeom>
           <a:solidFill>
-            <a:srgbClr val="F7F7F7"/>
+            <a:srgbClr val="F5F5F5"/>
           </a:solidFill>
           <a:ln>
             <a:noFill/>
@@ -5943,13 +6055,13 @@
       </p:sp>
       <p:sp>
         <p:nvSpPr>
-          <p:cNvPr id="24" name="TextBox 23"/>
+          <p:cNvPr id="27" name="TextBox 26"/>
           <p:cNvSpPr txBox="1"/>
           <p:nvPr/>
         </p:nvSpPr>
         <p:spPr>
           <a:xfrm>
-            <a:off x="5796000" y="2340000"/>
+            <a:off x="5868000" y="3672000"/>
             <a:ext cx="2700000" cy="468000"/>
           </a:xfrm>
           <a:prstGeom prst="rect">
@@ -5970,117 +6082,6 @@
                   <a:srgbClr val="111111"/>
                 </a:solidFill>
               </a:rPr>
-              <a:t>ES / EN</a:t>
-            </a:r>
-          </a:p>
-        </p:txBody>
-      </p:sp>
-      <p:sp>
-        <p:nvSpPr>
-          <p:cNvPr id="25" name="TextBox 24"/>
-          <p:cNvSpPr txBox="1"/>
-          <p:nvPr/>
-        </p:nvSpPr>
-        <p:spPr>
-          <a:xfrm>
-            <a:off x="5796000" y="2844000"/>
-            <a:ext cx="2700000" cy="288000"/>
-          </a:xfrm>
-          <a:prstGeom prst="rect">
-            <a:avLst/>
-          </a:prstGeom>
-          <a:noFill/>
-        </p:spPr>
-        <p:txBody>
-          <a:bodyPr wrap="square">
-            <a:spAutoFit/>
-          </a:bodyPr>
-          <a:lstStyle/>
-          <a:p>
-            <a:pPr algn="l"/>
-            <a:r>
-              <a:rPr sz="750" b="0" i="0">
-                <a:solidFill>
-                  <a:srgbClr val="888888"/>
-                </a:solidFill>
-              </a:rPr>
-              <a:t>Distribución por idioma</a:t>
-            </a:r>
-          </a:p>
-        </p:txBody>
-      </p:sp>
-      <p:sp>
-        <p:nvSpPr>
-          <p:cNvPr id="26" name="Rectangle 25"/>
-          <p:cNvSpPr/>
-          <p:nvPr/>
-        </p:nvSpPr>
-        <p:spPr>
-          <a:xfrm>
-            <a:off x="5616000" y="3383999"/>
-            <a:ext cx="3060000" cy="1007999"/>
-          </a:xfrm>
-          <a:prstGeom prst="rect">
-            <a:avLst/>
-          </a:prstGeom>
-          <a:solidFill>
-            <a:srgbClr val="F7F7F7"/>
-          </a:solidFill>
-          <a:ln>
-            <a:noFill/>
-          </a:ln>
-        </p:spPr>
-        <p:style>
-          <a:lnRef idx="1">
-            <a:schemeClr val="accent1"/>
-          </a:lnRef>
-          <a:fillRef idx="3">
-            <a:schemeClr val="accent1"/>
-          </a:fillRef>
-          <a:effectRef idx="2">
-            <a:schemeClr val="accent1"/>
-          </a:effectRef>
-          <a:fontRef idx="minor">
-            <a:schemeClr val="lt1"/>
-          </a:fontRef>
-        </p:style>
-        <p:txBody>
-          <a:bodyPr rtlCol="0" anchor="ctr"/>
-          <a:lstStyle/>
-          <a:p>
-            <a:pPr algn="ctr"/>
-          </a:p>
-        </p:txBody>
-      </p:sp>
-      <p:sp>
-        <p:nvSpPr>
-          <p:cNvPr id="27" name="TextBox 26"/>
-          <p:cNvSpPr txBox="1"/>
-          <p:nvPr/>
-        </p:nvSpPr>
-        <p:spPr>
-          <a:xfrm>
-            <a:off x="5796000" y="3527999"/>
-            <a:ext cx="2700000" cy="468000"/>
-          </a:xfrm>
-          <a:prstGeom prst="rect">
-            <a:avLst/>
-          </a:prstGeom>
-          <a:noFill/>
-        </p:spPr>
-        <p:txBody>
-          <a:bodyPr wrap="square">
-            <a:spAutoFit/>
-          </a:bodyPr>
-          <a:lstStyle/>
-          <a:p>
-            <a:pPr algn="l"/>
-            <a:r>
-              <a:rPr sz="1800" b="1" i="0">
-                <a:solidFill>
-                  <a:srgbClr val="111111"/>
-                </a:solidFill>
-              </a:rPr>
               <a:t>Nivel</a:t>
             </a:r>
           </a:p>
@@ -6094,7 +6095,7 @@
         </p:nvSpPr>
         <p:spPr>
           <a:xfrm>
-            <a:off x="5796000" y="4031999"/>
+            <a:off x="5868000" y="4176000"/>
             <a:ext cx="2700000" cy="288000"/>
           </a:xfrm>
           <a:prstGeom prst="rect">
@@ -6155,7 +6156,7 @@
         <p:spPr>
           <a:xfrm>
             <a:off x="0" y="0"/>
-            <a:ext cx="3780000" cy="5148000"/>
+            <a:ext cx="3888000" cy="5148000"/>
           </a:xfrm>
           <a:prstGeom prst="rect">
             <a:avLst/>
@@ -6197,8 +6198,8 @@
         </p:nvSpPr>
         <p:spPr>
           <a:xfrm>
-            <a:off x="540000" y="720000"/>
-            <a:ext cx="2880000" cy="360000"/>
+            <a:off x="540000" y="648000"/>
+            <a:ext cx="3060000" cy="324000"/>
           </a:xfrm>
           <a:prstGeom prst="rect">
             <a:avLst/>
@@ -6231,8 +6232,8 @@
         </p:nvSpPr>
         <p:spPr>
           <a:xfrm>
-            <a:off x="540000" y="1080000"/>
-            <a:ext cx="2880000" cy="1800000"/>
+            <a:off x="540000" y="1007999"/>
+            <a:ext cx="3060000" cy="1800000"/>
           </a:xfrm>
           <a:prstGeom prst="rect">
             <a:avLst/>
@@ -6265,8 +6266,8 @@
         </p:nvSpPr>
         <p:spPr>
           <a:xfrm>
-            <a:off x="540000" y="3060000"/>
-            <a:ext cx="2880000" cy="900000"/>
+            <a:off x="540000" y="3024000"/>
+            <a:ext cx="3060000" cy="900000"/>
           </a:xfrm>
           <a:prstGeom prst="rect">
             <a:avLst/>
@@ -6300,8 +6301,8 @@
         </p:nvSpPr>
         <p:spPr>
           <a:xfrm>
-            <a:off x="4140000" y="540000"/>
-            <a:ext cx="4500000" cy="936000"/>
+            <a:off x="4140000" y="503999"/>
+            <a:ext cx="4680000" cy="936000"/>
           </a:xfrm>
           <a:prstGeom prst="rect">
             <a:avLst/>
@@ -6336,7 +6337,7 @@
         <p:spPr>
           <a:xfrm>
             <a:off x="4140000" y="1728000"/>
-            <a:ext cx="288000" cy="324000"/>
+            <a:ext cx="324000" cy="324000"/>
           </a:xfrm>
           <a:prstGeom prst="rect">
             <a:avLst/>
@@ -6369,8 +6370,8 @@
         </p:nvSpPr>
         <p:spPr>
           <a:xfrm>
-            <a:off x="4428000" y="1728000"/>
-            <a:ext cx="4140000" cy="503999"/>
+            <a:off x="4500000" y="1728000"/>
+            <a:ext cx="4320000" cy="503999"/>
           </a:xfrm>
           <a:prstGeom prst="rect">
             <a:avLst/>
@@ -6390,7 +6391,7 @@
                   <a:srgbClr val="888888"/>
                 </a:solidFill>
               </a:rPr>
-              <a:t>Página oficial en la app, creada y mantenida por nosotros</a:t>
+              <a:t>Página oficial en la app, creada por nosotros</a:t>
             </a:r>
           </a:p>
         </p:txBody>
@@ -6403,17 +6404,17 @@
         </p:nvSpPr>
         <p:spPr>
           <a:xfrm>
-            <a:off x="4140000" y="2268000"/>
-            <a:ext cx="4320000" cy="0"/>
-          </a:xfrm>
-          <a:prstGeom prst="rect">
-            <a:avLst/>
-          </a:prstGeom>
-          <a:noFill/>
-          <a:ln w="12700">
-            <a:solidFill>
-              <a:srgbClr val="333333"/>
-            </a:solidFill>
+            <a:off x="4140000" y="2286000"/>
+            <a:ext cx="4500000" cy="7200"/>
+          </a:xfrm>
+          <a:prstGeom prst="rect">
+            <a:avLst/>
+          </a:prstGeom>
+          <a:solidFill>
+            <a:srgbClr val="333333"/>
+          </a:solidFill>
+          <a:ln>
+            <a:noFill/>
           </a:ln>
         </p:spPr>
         <p:style>
@@ -6446,8 +6447,8 @@
         </p:nvSpPr>
         <p:spPr>
           <a:xfrm>
-            <a:off x="4140000" y="2340000"/>
-            <a:ext cx="288000" cy="324000"/>
+            <a:off x="4140000" y="2358000"/>
+            <a:ext cx="324000" cy="324000"/>
           </a:xfrm>
           <a:prstGeom prst="rect">
             <a:avLst/>
@@ -6480,8 +6481,8 @@
         </p:nvSpPr>
         <p:spPr>
           <a:xfrm>
-            <a:off x="4428000" y="2340000"/>
-            <a:ext cx="4140000" cy="503999"/>
+            <a:off x="4500000" y="2358000"/>
+            <a:ext cx="4320000" cy="503999"/>
           </a:xfrm>
           <a:prstGeom prst="rect">
             <a:avLst/>
@@ -6501,7 +6502,7 @@
                   <a:srgbClr val="888888"/>
                 </a:solidFill>
               </a:rPr>
-              <a:t>Colección curada de obras enlazadas directamente</a:t>
+              <a:t>Colección curada de obras enlazadas</a:t>
             </a:r>
           </a:p>
         </p:txBody>
@@ -6514,17 +6515,17 @@
         </p:nvSpPr>
         <p:spPr>
           <a:xfrm>
-            <a:off x="4140000" y="2880000"/>
-            <a:ext cx="4320000" cy="0"/>
-          </a:xfrm>
-          <a:prstGeom prst="rect">
-            <a:avLst/>
-          </a:prstGeom>
-          <a:noFill/>
-          <a:ln w="12700">
-            <a:solidFill>
-              <a:srgbClr val="333333"/>
-            </a:solidFill>
+            <a:off x="4140000" y="2916000"/>
+            <a:ext cx="4500000" cy="7200"/>
+          </a:xfrm>
+          <a:prstGeom prst="rect">
+            <a:avLst/>
+          </a:prstGeom>
+          <a:solidFill>
+            <a:srgbClr val="333333"/>
+          </a:solidFill>
+          <a:ln>
+            <a:noFill/>
           </a:ln>
         </p:spPr>
         <p:style>
@@ -6557,8 +6558,8 @@
         </p:nvSpPr>
         <p:spPr>
           <a:xfrm>
-            <a:off x="4140000" y="2951999"/>
-            <a:ext cx="288000" cy="324000"/>
+            <a:off x="4140000" y="2988000"/>
+            <a:ext cx="324000" cy="324000"/>
           </a:xfrm>
           <a:prstGeom prst="rect">
             <a:avLst/>
@@ -6591,8 +6592,8 @@
         </p:nvSpPr>
         <p:spPr>
           <a:xfrm>
-            <a:off x="4428000" y="2951999"/>
-            <a:ext cx="4140000" cy="503999"/>
+            <a:off x="4500000" y="2988000"/>
+            <a:ext cx="4320000" cy="503999"/>
           </a:xfrm>
           <a:prstGeom prst="rect">
             <a:avLst/>
@@ -6612,7 +6613,7 @@
                   <a:srgbClr val="888888"/>
                 </a:solidFill>
               </a:rPr>
-              <a:t>QR listos para imprimir y colocar junto a las obras</a:t>
+              <a:t>QR listos para imprimir junto a cada obra</a:t>
             </a:r>
           </a:p>
         </p:txBody>
@@ -6625,17 +6626,17 @@
         </p:nvSpPr>
         <p:spPr>
           <a:xfrm>
-            <a:off x="4140000" y="3491999"/>
-            <a:ext cx="4320000" cy="0"/>
-          </a:xfrm>
-          <a:prstGeom prst="rect">
-            <a:avLst/>
-          </a:prstGeom>
-          <a:noFill/>
-          <a:ln w="12700">
-            <a:solidFill>
-              <a:srgbClr val="333333"/>
-            </a:solidFill>
+            <a:off x="4140000" y="3546000"/>
+            <a:ext cx="4500000" cy="7200"/>
+          </a:xfrm>
+          <a:prstGeom prst="rect">
+            <a:avLst/>
+          </a:prstGeom>
+          <a:solidFill>
+            <a:srgbClr val="333333"/>
+          </a:solidFill>
+          <a:ln>
+            <a:noFill/>
           </a:ln>
         </p:spPr>
         <p:style>
@@ -6668,8 +6669,8 @@
         </p:nvSpPr>
         <p:spPr>
           <a:xfrm>
-            <a:off x="4140000" y="3563999"/>
-            <a:ext cx="288000" cy="324000"/>
+            <a:off x="4140000" y="3618000"/>
+            <a:ext cx="324000" cy="324000"/>
           </a:xfrm>
           <a:prstGeom prst="rect">
             <a:avLst/>
@@ -6702,8 +6703,8 @@
         </p:nvSpPr>
         <p:spPr>
           <a:xfrm>
-            <a:off x="4428000" y="3563999"/>
-            <a:ext cx="4140000" cy="503999"/>
+            <a:off x="4500000" y="3618000"/>
+            <a:ext cx="4320000" cy="503999"/>
           </a:xfrm>
           <a:prstGeom prst="rect">
             <a:avLst/>
@@ -6723,7 +6724,7 @@
                   <a:srgbClr val="888888"/>
                 </a:solidFill>
               </a:rPr>
-              <a:t>Informe mensual con datos reales de tus visitantes</a:t>
+              <a:t>Informe mensual con datos reales de visitantes</a:t>
             </a:r>
           </a:p>
         </p:txBody>
@@ -6736,17 +6737,17 @@
         </p:nvSpPr>
         <p:spPr>
           <a:xfrm>
-            <a:off x="4140000" y="4103999"/>
-            <a:ext cx="4320000" cy="0"/>
-          </a:xfrm>
-          <a:prstGeom prst="rect">
-            <a:avLst/>
-          </a:prstGeom>
-          <a:noFill/>
-          <a:ln w="12700">
-            <a:solidFill>
-              <a:srgbClr val="333333"/>
-            </a:solidFill>
+            <a:off x="4140000" y="4176000"/>
+            <a:ext cx="4500000" cy="7200"/>
+          </a:xfrm>
+          <a:prstGeom prst="rect">
+            <a:avLst/>
+          </a:prstGeom>
+          <a:solidFill>
+            <a:srgbClr val="333333"/>
+          </a:solidFill>
+          <a:ln>
+            <a:noFill/>
           </a:ln>
         </p:spPr>
         <p:style>
@@ -6779,8 +6780,8 @@
         </p:nvSpPr>
         <p:spPr>
           <a:xfrm>
-            <a:off x="4140000" y="4248000"/>
-            <a:ext cx="4320000" cy="432000"/>
+            <a:off x="4140000" y="4320000"/>
+            <a:ext cx="4500000" cy="432000"/>
           </a:xfrm>
           <a:prstGeom prst="rect">
             <a:avLst/>
@@ -6822,8 +6823,8 @@
         </p:nvSpPr>
         <p:spPr>
           <a:xfrm>
-            <a:off x="4140000" y="4266000"/>
-            <a:ext cx="4320000" cy="396000"/>
+            <a:off x="4140000" y="4356000"/>
+            <a:ext cx="4500000" cy="396000"/>
           </a:xfrm>
           <a:prstGeom prst="rect">
             <a:avLst/>

</xml_diff>